<commit_message>
Cap nhat Ke hoach to chuyen mon THCS, KHDH Robotics TH lop 5, thong ke cuoc thi va cac tai lieu lien quan
</commit_message>
<xml_diff>
--- a/KHBD_Tin_học/Lớp_3/Tuần_08/Slide_Tin_hoc_Lớp_3_Tiet07_Bai_4_Lam_viec_voi_may_tinh_Tiet_1.pptx
+++ b/KHBD_Tin_học/Lớp_3/Tuần_08/Slide_Tin_hoc_Lớp_3_Tiet07_Bai_4_Lam_viec_voi_may_tinh_Tiet_1.pptx
@@ -5,12 +5,12 @@
     <p:sldMasterId id="2147483648" r:id="rId1"/>
   </p:sldMasterIdLst>
   <p:sldIdLst>
-    <p:sldId id="256" r:id="rId5"/>
-    <p:sldId id="257" r:id="rId4"/>
-    <p:sldId id="258" r:id="rId3"/>
-    <p:sldId id="259" r:id="rId2"/>
-    <p:sldId id="260" r:id="rId10"/>
-    <p:sldId id="261" r:id="rId11"/>
+    <p:sldId id="256" r:id="rId2"/>
+    <p:sldId id="257" r:id="rId3"/>
+    <p:sldId id="258" r:id="rId4"/>
+    <p:sldId id="259" r:id="rId5"/>
+    <p:sldId id="260" r:id="rId6"/>
+    <p:sldId id="261" r:id="rId7"/>
   </p:sldIdLst>
   <p:sldSz cx="12192000" cy="6858000"/>
   <p:notesSz cx="6858000" cy="9144000"/>
@@ -109,6 +109,11 @@
       </a:defRPr>
     </a:lvl9pPr>
   </p:defaultTextStyle>
+  <p:extLst>
+    <p:ext uri="{EFAFB233-063F-42B5-8137-9DF3F51BA10A}">
+      <p15:sldGuideLst xmlns:p15="http://schemas.microsoft.com/office/powerpoint/2012/main"/>
+    </p:ext>
+  </p:extLst>
 </p:presentation>
 </file>
 
@@ -259,7 +264,7 @@
           <a:p>
             <a:fld id="{4EA7EFA5-8E37-463D-AE92-97FC5095B482}" type="datetimeFigureOut">
               <a:rPr lang="en-US" smtClean="0"/>
-              <a:t>8/4/2026</a:t>
+              <a:t>9/16/2026</a:t>
             </a:fld>
             <a:endParaRPr lang="en-US"/>
           </a:p>
@@ -457,7 +462,7 @@
           <a:p>
             <a:fld id="{4EA7EFA5-8E37-463D-AE92-97FC5095B482}" type="datetimeFigureOut">
               <a:rPr lang="en-US" smtClean="0"/>
-              <a:t>8/4/2026</a:t>
+              <a:t>9/16/2026</a:t>
             </a:fld>
             <a:endParaRPr lang="en-US"/>
           </a:p>
@@ -665,7 +670,7 @@
           <a:p>
             <a:fld id="{4EA7EFA5-8E37-463D-AE92-97FC5095B482}" type="datetimeFigureOut">
               <a:rPr lang="en-US" smtClean="0"/>
-              <a:t>8/4/2026</a:t>
+              <a:t>9/16/2026</a:t>
             </a:fld>
             <a:endParaRPr lang="en-US"/>
           </a:p>
@@ -863,7 +868,7 @@
           <a:p>
             <a:fld id="{4EA7EFA5-8E37-463D-AE92-97FC5095B482}" type="datetimeFigureOut">
               <a:rPr lang="en-US" smtClean="0"/>
-              <a:t>8/4/2026</a:t>
+              <a:t>9/16/2026</a:t>
             </a:fld>
             <a:endParaRPr lang="en-US"/>
           </a:p>
@@ -1138,7 +1143,7 @@
           <a:p>
             <a:fld id="{4EA7EFA5-8E37-463D-AE92-97FC5095B482}" type="datetimeFigureOut">
               <a:rPr lang="en-US" smtClean="0"/>
-              <a:t>8/4/2026</a:t>
+              <a:t>9/16/2026</a:t>
             </a:fld>
             <a:endParaRPr lang="en-US"/>
           </a:p>
@@ -1403,7 +1408,7 @@
           <a:p>
             <a:fld id="{4EA7EFA5-8E37-463D-AE92-97FC5095B482}" type="datetimeFigureOut">
               <a:rPr lang="en-US" smtClean="0"/>
-              <a:t>8/4/2026</a:t>
+              <a:t>9/16/2026</a:t>
             </a:fld>
             <a:endParaRPr lang="en-US"/>
           </a:p>
@@ -1815,7 +1820,7 @@
           <a:p>
             <a:fld id="{4EA7EFA5-8E37-463D-AE92-97FC5095B482}" type="datetimeFigureOut">
               <a:rPr lang="en-US" smtClean="0"/>
-              <a:t>8/4/2026</a:t>
+              <a:t>9/16/2026</a:t>
             </a:fld>
             <a:endParaRPr lang="en-US"/>
           </a:p>
@@ -1956,7 +1961,7 @@
           <a:p>
             <a:fld id="{4EA7EFA5-8E37-463D-AE92-97FC5095B482}" type="datetimeFigureOut">
               <a:rPr lang="en-US" smtClean="0"/>
-              <a:t>8/4/2026</a:t>
+              <a:t>9/16/2026</a:t>
             </a:fld>
             <a:endParaRPr lang="en-US"/>
           </a:p>
@@ -2069,7 +2074,7 @@
           <a:p>
             <a:fld id="{4EA7EFA5-8E37-463D-AE92-97FC5095B482}" type="datetimeFigureOut">
               <a:rPr lang="en-US" smtClean="0"/>
-              <a:t>8/4/2026</a:t>
+              <a:t>9/16/2026</a:t>
             </a:fld>
             <a:endParaRPr lang="en-US"/>
           </a:p>
@@ -2380,7 +2385,7 @@
           <a:p>
             <a:fld id="{4EA7EFA5-8E37-463D-AE92-97FC5095B482}" type="datetimeFigureOut">
               <a:rPr lang="en-US" smtClean="0"/>
-              <a:t>8/4/2026</a:t>
+              <a:t>9/16/2026</a:t>
             </a:fld>
             <a:endParaRPr lang="en-US"/>
           </a:p>
@@ -2668,7 +2673,7 @@
           <a:p>
             <a:fld id="{4EA7EFA5-8E37-463D-AE92-97FC5095B482}" type="datetimeFigureOut">
               <a:rPr lang="en-US" smtClean="0"/>
-              <a:t>8/4/2026</a:t>
+              <a:t>9/16/2026</a:t>
             </a:fld>
             <a:endParaRPr lang="en-US"/>
           </a:p>
@@ -2909,7 +2914,7 @@
           <a:p>
             <a:fld id="{4EA7EFA5-8E37-463D-AE92-97FC5095B482}" type="datetimeFigureOut">
               <a:rPr lang="en-US" smtClean="0"/>
-              <a:t>8/4/2026</a:t>
+              <a:t>9/16/2026</a:t>
             </a:fld>
             <a:endParaRPr lang="en-US"/>
           </a:p>
@@ -3383,7 +3388,7 @@
 </file>
 
 <file path=ppt/slides/slide1.xml><?xml version="1.0" encoding="utf-8"?>
-<p:sld xmlns:a="http://schemas.openxmlformats.org/drawingml/2006/main" xmlns:p="http://schemas.openxmlformats.org/presentationml/2006/main" xmlns:r="http://schemas.openxmlformats.org/officeDocument/2006/relationships">
+<p:sld xmlns:a="http://schemas.openxmlformats.org/drawingml/2006/main" xmlns:r="http://schemas.openxmlformats.org/officeDocument/2006/relationships" xmlns:p="http://schemas.openxmlformats.org/presentationml/2006/main">
   <p:cSld>
     <p:spTree>
       <p:nvGrpSpPr>
@@ -3391,7 +3396,14 @@
         <p:cNvGrpSpPr/>
         <p:nvPr/>
       </p:nvGrpSpPr>
-      <p:grpSpPr/>
+      <p:grpSpPr>
+        <a:xfrm>
+          <a:off x="0" y="0"/>
+          <a:ext cx="0" cy="0"/>
+          <a:chOff x="0" y="0"/>
+          <a:chExt cx="0" cy="0"/>
+        </a:xfrm>
+      </p:grpSpPr>
       <p:sp>
         <p:nvSpPr>
           <p:cNvPr id="2" name="Rectangle 1"/>
@@ -3432,6 +3444,7 @@
           <a:lstStyle/>
           <a:p>
             <a:pPr algn="ctr"/>
+            <a:endParaRPr/>
           </a:p>
         </p:txBody>
       </p:sp>
@@ -3473,7 +3486,7 @@
           </a:fontRef>
         </p:style>
         <p:txBody>
-          <a:bodyPr rtlCol="0" anchor="ctr" wrap="none"/>
+          <a:bodyPr wrap="none" rtlCol="0" anchor="ctr"/>
           <a:lstStyle/>
           <a:p>
             <a:pPr algn="ctr">
@@ -3599,7 +3612,7 @@
 </file>
 
 <file path=ppt/slides/slide2.xml><?xml version="1.0" encoding="utf-8"?>
-<p:sld xmlns:a="http://schemas.openxmlformats.org/drawingml/2006/main" xmlns:p="http://schemas.openxmlformats.org/presentationml/2006/main" xmlns:r="http://schemas.openxmlformats.org/officeDocument/2006/relationships">
+<p:sld xmlns:a="http://schemas.openxmlformats.org/drawingml/2006/main" xmlns:r="http://schemas.openxmlformats.org/officeDocument/2006/relationships" xmlns:p="http://schemas.openxmlformats.org/presentationml/2006/main">
   <p:cSld>
     <p:spTree>
       <p:nvGrpSpPr>
@@ -3607,7 +3620,14 @@
         <p:cNvGrpSpPr/>
         <p:nvPr/>
       </p:nvGrpSpPr>
-      <p:grpSpPr/>
+      <p:grpSpPr>
+        <a:xfrm>
+          <a:off x="0" y="0"/>
+          <a:ext cx="0" cy="0"/>
+          <a:chOff x="0" y="0"/>
+          <a:chExt cx="0" cy="0"/>
+        </a:xfrm>
+      </p:grpSpPr>
       <p:sp>
         <p:nvSpPr>
           <p:cNvPr id="2" name="Rounded Rectangle 1"/>
@@ -3646,7 +3666,7 @@
           </a:fontRef>
         </p:style>
         <p:txBody>
-          <a:bodyPr rtlCol="0" anchor="ctr" wrap="none"/>
+          <a:bodyPr wrap="none" rtlCol="0" anchor="ctr"/>
           <a:lstStyle/>
           <a:p>
             <a:pPr algn="ctr">
@@ -3743,6 +3763,7 @@
           <a:lstStyle/>
           <a:p>
             <a:pPr algn="ctr"/>
+            <a:endParaRPr/>
           </a:p>
         </p:txBody>
       </p:sp>
@@ -3834,7 +3855,7 @@
 </file>
 
 <file path=ppt/slides/slide3.xml><?xml version="1.0" encoding="utf-8"?>
-<p:sld xmlns:a="http://schemas.openxmlformats.org/drawingml/2006/main" xmlns:p="http://schemas.openxmlformats.org/presentationml/2006/main" xmlns:r="http://schemas.openxmlformats.org/officeDocument/2006/relationships">
+<p:sld xmlns:a="http://schemas.openxmlformats.org/drawingml/2006/main" xmlns:r="http://schemas.openxmlformats.org/officeDocument/2006/relationships" xmlns:p="http://schemas.openxmlformats.org/presentationml/2006/main">
   <p:cSld>
     <p:spTree>
       <p:nvGrpSpPr>
@@ -3842,7 +3863,14 @@
         <p:cNvGrpSpPr/>
         <p:nvPr/>
       </p:nvGrpSpPr>
-      <p:grpSpPr/>
+      <p:grpSpPr>
+        <a:xfrm>
+          <a:off x="0" y="0"/>
+          <a:ext cx="0" cy="0"/>
+          <a:chOff x="0" y="0"/>
+          <a:chExt cx="0" cy="0"/>
+        </a:xfrm>
+      </p:grpSpPr>
       <p:sp>
         <p:nvSpPr>
           <p:cNvPr id="2" name="Rounded Rectangle 1"/>
@@ -3881,7 +3909,7 @@
           </a:fontRef>
         </p:style>
         <p:txBody>
-          <a:bodyPr rtlCol="0" anchor="ctr" wrap="none"/>
+          <a:bodyPr wrap="none" rtlCol="0" anchor="ctr"/>
           <a:lstStyle/>
           <a:p>
             <a:pPr algn="ctr">
@@ -3951,7 +3979,7 @@
         <p:spPr>
           <a:xfrm>
             <a:off x="731520" y="2011680"/>
-            <a:ext cx="10698480" cy="3566160"/>
+            <a:ext cx="11192256" cy="3730752"/>
           </a:xfrm>
           <a:prstGeom prst="rect">
             <a:avLst/>
@@ -3967,7 +3995,7 @@
 </file>
 
 <file path=ppt/slides/slide4.xml><?xml version="1.0" encoding="utf-8"?>
-<p:sld xmlns:a="http://schemas.openxmlformats.org/drawingml/2006/main" xmlns:p="http://schemas.openxmlformats.org/presentationml/2006/main" xmlns:r="http://schemas.openxmlformats.org/officeDocument/2006/relationships">
+<p:sld xmlns:a="http://schemas.openxmlformats.org/drawingml/2006/main" xmlns:r="http://schemas.openxmlformats.org/officeDocument/2006/relationships" xmlns:p="http://schemas.openxmlformats.org/presentationml/2006/main">
   <p:cSld>
     <p:spTree>
       <p:nvGrpSpPr>
@@ -3975,7 +4003,14 @@
         <p:cNvGrpSpPr/>
         <p:nvPr/>
       </p:nvGrpSpPr>
-      <p:grpSpPr/>
+      <p:grpSpPr>
+        <a:xfrm>
+          <a:off x="0" y="0"/>
+          <a:ext cx="0" cy="0"/>
+          <a:chOff x="0" y="0"/>
+          <a:chExt cx="0" cy="0"/>
+        </a:xfrm>
+      </p:grpSpPr>
       <p:sp>
         <p:nvSpPr>
           <p:cNvPr id="2" name="Rounded Rectangle 1"/>
@@ -4014,7 +4049,7 @@
           </a:fontRef>
         </p:style>
         <p:txBody>
-          <a:bodyPr rtlCol="0" anchor="ctr" wrap="none"/>
+          <a:bodyPr wrap="none" rtlCol="0" anchor="ctr"/>
           <a:lstStyle/>
           <a:p>
             <a:pPr algn="ctr">
@@ -4111,6 +4146,7 @@
           <a:lstStyle/>
           <a:p>
             <a:pPr algn="ctr"/>
+            <a:endParaRPr/>
           </a:p>
         </p:txBody>
       </p:sp>
@@ -4211,6 +4247,7 @@
           <a:lstStyle/>
           <a:p>
             <a:pPr algn="ctr"/>
+            <a:endParaRPr/>
           </a:p>
         </p:txBody>
       </p:sp>
@@ -4276,7 +4313,7 @@
 </file>
 
 <file path=ppt/slides/slide5.xml><?xml version="1.0" encoding="utf-8"?>
-<p:sld xmlns:a="http://schemas.openxmlformats.org/drawingml/2006/main" xmlns:p="http://schemas.openxmlformats.org/presentationml/2006/main" xmlns:r="http://schemas.openxmlformats.org/officeDocument/2006/relationships">
+<p:sld xmlns:a="http://schemas.openxmlformats.org/drawingml/2006/main" xmlns:r="http://schemas.openxmlformats.org/officeDocument/2006/relationships" xmlns:p="http://schemas.openxmlformats.org/presentationml/2006/main">
   <p:cSld>
     <p:spTree>
       <p:nvGrpSpPr>
@@ -4284,7 +4321,14 @@
         <p:cNvGrpSpPr/>
         <p:nvPr/>
       </p:nvGrpSpPr>
-      <p:grpSpPr/>
+      <p:grpSpPr>
+        <a:xfrm>
+          <a:off x="0" y="0"/>
+          <a:ext cx="0" cy="0"/>
+          <a:chOff x="0" y="0"/>
+          <a:chExt cx="0" cy="0"/>
+        </a:xfrm>
+      </p:grpSpPr>
       <p:sp>
         <p:nvSpPr>
           <p:cNvPr id="2" name="Rounded Rectangle 1"/>
@@ -4323,7 +4367,7 @@
           </a:fontRef>
         </p:style>
         <p:txBody>
-          <a:bodyPr rtlCol="0" anchor="ctr" wrap="none"/>
+          <a:bodyPr wrap="none" rtlCol="0" anchor="ctr"/>
           <a:lstStyle/>
           <a:p>
             <a:pPr algn="ctr">
@@ -4420,6 +4464,7 @@
           <a:lstStyle/>
           <a:p>
             <a:pPr algn="ctr"/>
+            <a:endParaRPr/>
           </a:p>
         </p:txBody>
       </p:sp>
@@ -4465,6 +4510,7 @@
           <a:lstStyle/>
           <a:p>
             <a:pPr algn="ctr"/>
+            <a:endParaRPr/>
           </a:p>
         </p:txBody>
       </p:sp>
@@ -4600,7 +4646,7 @@
 </file>
 
 <file path=ppt/slides/slide6.xml><?xml version="1.0" encoding="utf-8"?>
-<p:sld xmlns:a="http://schemas.openxmlformats.org/drawingml/2006/main" xmlns:p="http://schemas.openxmlformats.org/presentationml/2006/main" xmlns:r="http://schemas.openxmlformats.org/officeDocument/2006/relationships">
+<p:sld xmlns:a="http://schemas.openxmlformats.org/drawingml/2006/main" xmlns:r="http://schemas.openxmlformats.org/officeDocument/2006/relationships" xmlns:p="http://schemas.openxmlformats.org/presentationml/2006/main">
   <p:cSld>
     <p:spTree>
       <p:nvGrpSpPr>
@@ -4608,7 +4654,14 @@
         <p:cNvGrpSpPr/>
         <p:nvPr/>
       </p:nvGrpSpPr>
-      <p:grpSpPr/>
+      <p:grpSpPr>
+        <a:xfrm>
+          <a:off x="0" y="0"/>
+          <a:ext cx="0" cy="0"/>
+          <a:chOff x="0" y="0"/>
+          <a:chExt cx="0" cy="0"/>
+        </a:xfrm>
+      </p:grpSpPr>
       <p:sp>
         <p:nvSpPr>
           <p:cNvPr id="2" name="Rectangle 1"/>
@@ -4649,6 +4702,7 @@
           <a:lstStyle/>
           <a:p>
             <a:pPr algn="ctr"/>
+            <a:endParaRPr/>
           </a:p>
         </p:txBody>
       </p:sp>

</xml_diff>